<commit_message>
docs: remove 30-day free trial from presentation
</commit_message>
<xml_diff>
--- a/CortexCLMS-Presentation.pptx
+++ b/CortexCLMS-Presentation.pptx
@@ -7508,7 +7508,7 @@
                   <a:srgbClr val="888888"/>
                 </a:solidFill>
               </a:rPr>
-              <a:t>* All plans include: Free Setup, Data Migration Assistance, User Training, 30-day free trial period, and 1-year bug-fix warranty.</a:t>
+              <a:t>* All plans include: Free Setup, Data Migration Assistance, User Training, and 1-year bug-fix warranty.</a:t>
             </a:r>
           </a:p>
         </p:txBody>
@@ -16754,7 +16754,7 @@
                   <a:srgbClr val="FFFFFF"/>
                 </a:solidFill>
               </a:rPr>
-              <a:t>30-Day Free Trial</a:t>
+              <a:t>Pilot Implementation</a:t>
             </a:r>
           </a:p>
         </p:txBody>
@@ -16788,7 +16788,7 @@
                   <a:srgbClr val="AABBCC"/>
                 </a:solidFill>
               </a:rPr>
-              <a:t>Get full access to all features. Your data, your lab — zero commitment.</a:t>
+              <a:t>We set up your lab data, configure workflows, and run a pilot with your team — hands-on and guided.</a:t>
             </a:r>
           </a:p>
         </p:txBody>

</xml_diff>

<commit_message>
docs: update PPT and user manual with Cortex AI Technologies branding and contact details
- PPT cover slide: render Cortex AI Technologies logo (red bar + CORTEX + AI TECHNOLOGIES
  band) and CortexCLMS logo (Cortex navy + CLMS cyan) using shapes/text
- PPT cover: add contact line (phone, email, address) at bottom
- PPT CTA slide: replace placeholder contact with real details —
  +91 8329925318 | cortexaitechnologies@zohomail.in | Pune 411034
- Manual cover page: add both logo treatments (Cortex AI + CortexCLMS) in styled HTML,
  add contact block (phone/email/address)
- Manual back page: add combined logo row + contact footer strip

Co-Authored-By: Claude Sonnet 4.6 <noreply@anthropic.com>
Claude-Session: https://claude.ai/code/session_016HVzvducj4xMisoimRy6Tr
</commit_message>
<xml_diff>
--- a/CortexCLMS-Presentation.pptx
+++ b/CortexCLMS-Presentation.pptx
@@ -4167,8 +4167,8 @@
         </p:nvSpPr>
         <p:spPr>
           <a:xfrm>
-            <a:off x="548640" y="914400"/>
-            <a:ext cx="1005840" cy="1005840"/>
+            <a:off x="502920" y="914400"/>
+            <a:ext cx="109728" cy="822960"/>
           </a:xfrm>
           <a:prstGeom prst="rect">
             <a:avLst/>
@@ -4210,42 +4210,119 @@
         </p:nvSpPr>
         <p:spPr>
           <a:xfrm>
-            <a:off x="566928" y="960120"/>
-            <a:ext cx="1005840" cy="914400"/>
-          </a:xfrm>
-          <a:prstGeom prst="rect">
-            <a:avLst/>
-          </a:prstGeom>
-          <a:noFill/>
-        </p:spPr>
-        <p:txBody>
-          <a:bodyPr wrap="square">
-            <a:spAutoFit/>
-          </a:bodyPr>
-          <a:lstStyle/>
-          <a:p>
-            <a:pPr algn="ctr"/>
-            <a:r>
-              <a:rPr sz="3600" b="1" i="0">
+            <a:off x="658368" y="914400"/>
+            <a:ext cx="2743200" cy="502920"/>
+          </a:xfrm>
+          <a:prstGeom prst="rect">
+            <a:avLst/>
+          </a:prstGeom>
+          <a:noFill/>
+        </p:spPr>
+        <p:txBody>
+          <a:bodyPr wrap="square">
+            <a:spAutoFit/>
+          </a:bodyPr>
+          <a:lstStyle/>
+          <a:p>
+            <a:pPr algn="l"/>
+            <a:r>
+              <a:rPr sz="2800" b="1" i="0">
                 <a:solidFill>
                   <a:srgbClr val="FFFFFF"/>
                 </a:solidFill>
               </a:rPr>
-              <a:t>C</a:t>
-            </a:r>
-          </a:p>
-        </p:txBody>
-      </p:sp>
-      <p:sp>
-        <p:nvSpPr>
-          <p:cNvPr id="10" name="TextBox 9"/>
-          <p:cNvSpPr txBox="1"/>
-          <p:nvPr/>
-        </p:nvSpPr>
-        <p:spPr>
-          <a:xfrm>
-            <a:off x="1691640" y="914400"/>
-            <a:ext cx="8229600" cy="411480"/>
+              <a:t>CORTEX</a:t>
+            </a:r>
+          </a:p>
+        </p:txBody>
+      </p:sp>
+      <p:sp>
+        <p:nvSpPr>
+          <p:cNvPr id="10" name="Rectangle 9"/>
+          <p:cNvSpPr/>
+          <p:nvPr/>
+        </p:nvSpPr>
+        <p:spPr>
+          <a:xfrm>
+            <a:off x="658368" y="1417320"/>
+            <a:ext cx="2651760" cy="320040"/>
+          </a:xfrm>
+          <a:prstGeom prst="rect">
+            <a:avLst/>
+          </a:prstGeom>
+          <a:solidFill>
+            <a:srgbClr val="1A1A1A"/>
+          </a:solidFill>
+          <a:ln>
+            <a:noFill/>
+          </a:ln>
+        </p:spPr>
+        <p:style>
+          <a:lnRef idx="1">
+            <a:schemeClr val="accent1"/>
+          </a:lnRef>
+          <a:fillRef idx="3">
+            <a:schemeClr val="accent1"/>
+          </a:fillRef>
+          <a:effectRef idx="2">
+            <a:schemeClr val="accent1"/>
+          </a:effectRef>
+          <a:fontRef idx="minor">
+            <a:schemeClr val="lt1"/>
+          </a:fontRef>
+        </p:style>
+        <p:txBody>
+          <a:bodyPr rtlCol="0" anchor="ctr"/>
+          <a:lstStyle/>
+          <a:p>
+            <a:pPr algn="ctr"/>
+          </a:p>
+        </p:txBody>
+      </p:sp>
+      <p:sp>
+        <p:nvSpPr>
+          <p:cNvPr id="11" name="TextBox 10"/>
+          <p:cNvSpPr txBox="1"/>
+          <p:nvPr/>
+        </p:nvSpPr>
+        <p:spPr>
+          <a:xfrm>
+            <a:off x="658368" y="1435608"/>
+            <a:ext cx="2651760" cy="292608"/>
+          </a:xfrm>
+          <a:prstGeom prst="rect">
+            <a:avLst/>
+          </a:prstGeom>
+          <a:noFill/>
+        </p:spPr>
+        <p:txBody>
+          <a:bodyPr wrap="square">
+            <a:spAutoFit/>
+          </a:bodyPr>
+          <a:lstStyle/>
+          <a:p>
+            <a:pPr algn="ctr"/>
+            <a:r>
+              <a:rPr sz="950" b="1" i="0">
+                <a:solidFill>
+                  <a:srgbClr val="FFFFFF"/>
+                </a:solidFill>
+              </a:rPr>
+              <a:t>AI  TECHNOLOGIES</a:t>
+            </a:r>
+          </a:p>
+        </p:txBody>
+      </p:sp>
+      <p:sp>
+        <p:nvSpPr>
+          <p:cNvPr id="12" name="TextBox 11"/>
+          <p:cNvSpPr txBox="1"/>
+          <p:nvPr/>
+        </p:nvSpPr>
+        <p:spPr>
+          <a:xfrm>
+            <a:off x="1691640" y="1920240"/>
+            <a:ext cx="3657600" cy="1005840"/>
           </a:xfrm>
           <a:prstGeom prst="rect">
             <a:avLst/>
@@ -4260,26 +4337,26 @@
           <a:p>
             <a:pPr algn="l"/>
             <a:r>
-              <a:rPr sz="1100" b="1" i="0">
-                <a:solidFill>
-                  <a:srgbClr val="E94560"/>
-                </a:solidFill>
-              </a:rPr>
-              <a:t>CORTEX TECHNOLOGIES</a:t>
-            </a:r>
-          </a:p>
-        </p:txBody>
-      </p:sp>
-      <p:sp>
-        <p:nvSpPr>
-          <p:cNvPr id="11" name="TextBox 10"/>
-          <p:cNvSpPr txBox="1"/>
-          <p:nvPr/>
-        </p:nvSpPr>
-        <p:spPr>
-          <a:xfrm>
-            <a:off x="1691640" y="1371600"/>
-            <a:ext cx="8229600" cy="1280160"/>
+              <a:rPr sz="4800" b="1" i="0">
+                <a:solidFill>
+                  <a:srgbClr val="FFFFFF"/>
+                </a:solidFill>
+              </a:rPr>
+              <a:t>Cortex</a:t>
+            </a:r>
+          </a:p>
+        </p:txBody>
+      </p:sp>
+      <p:sp>
+        <p:nvSpPr>
+          <p:cNvPr id="13" name="TextBox 12"/>
+          <p:cNvSpPr txBox="1"/>
+          <p:nvPr/>
+        </p:nvSpPr>
+        <p:spPr>
+          <a:xfrm>
+            <a:off x="4919472" y="1920240"/>
+            <a:ext cx="4389120" cy="1005840"/>
           </a:xfrm>
           <a:prstGeom prst="rect">
             <a:avLst/>
@@ -4294,26 +4371,26 @@
           <a:p>
             <a:pPr algn="l"/>
             <a:r>
-              <a:rPr sz="5400" b="1" i="0">
-                <a:solidFill>
-                  <a:srgbClr val="FFFFFF"/>
-                </a:solidFill>
-              </a:rPr>
-              <a:t>CortexCLMS</a:t>
-            </a:r>
-          </a:p>
-        </p:txBody>
-      </p:sp>
-      <p:sp>
-        <p:nvSpPr>
-          <p:cNvPr id="12" name="TextBox 11"/>
-          <p:cNvSpPr txBox="1"/>
-          <p:nvPr/>
-        </p:nvSpPr>
-        <p:spPr>
-          <a:xfrm>
-            <a:off x="1691640" y="2697480"/>
-            <a:ext cx="8229600" cy="1097280"/>
+              <a:rPr sz="4800" b="1" i="0">
+                <a:solidFill>
+                  <a:srgbClr val="00BFFF"/>
+                </a:solidFill>
+              </a:rPr>
+              <a:t>CLMS</a:t>
+            </a:r>
+          </a:p>
+        </p:txBody>
+      </p:sp>
+      <p:sp>
+        <p:nvSpPr>
+          <p:cNvPr id="14" name="TextBox 13"/>
+          <p:cNvSpPr txBox="1"/>
+          <p:nvPr/>
+        </p:nvSpPr>
+        <p:spPr>
+          <a:xfrm>
+            <a:off x="1691640" y="2944368"/>
+            <a:ext cx="8229600" cy="1005840"/>
           </a:xfrm>
           <a:prstGeom prst="rect">
             <a:avLst/>
@@ -4328,7 +4405,7 @@
           <a:p>
             <a:pPr algn="l"/>
             <a:r>
-              <a:rPr sz="2200" b="0" i="0">
+              <a:rPr sz="2000" b="0" i="0">
                 <a:solidFill>
                   <a:srgbClr val="B0C4DE"/>
                 </a:solidFill>
@@ -4341,13 +4418,13 @@
       </p:sp>
       <p:sp>
         <p:nvSpPr>
-          <p:cNvPr id="13" name="Rectangle 12"/>
+          <p:cNvPr id="15" name="Rectangle 14"/>
           <p:cNvSpPr/>
           <p:nvPr/>
         </p:nvSpPr>
         <p:spPr>
           <a:xfrm>
-            <a:off x="1691640" y="3840480"/>
+            <a:off x="1691640" y="4114800"/>
             <a:ext cx="5029200" cy="36576"/>
           </a:xfrm>
           <a:prstGeom prst="rect">
@@ -4384,14 +4461,14 @@
       </p:sp>
       <p:sp>
         <p:nvSpPr>
-          <p:cNvPr id="14" name="TextBox 13"/>
-          <p:cNvSpPr txBox="1"/>
-          <p:nvPr/>
-        </p:nvSpPr>
-        <p:spPr>
-          <a:xfrm>
-            <a:off x="1691640" y="4023360"/>
-            <a:ext cx="8686800" cy="640080"/>
+          <p:cNvPr id="16" name="TextBox 15"/>
+          <p:cNvSpPr txBox="1"/>
+          <p:nvPr/>
+        </p:nvSpPr>
+        <p:spPr>
+          <a:xfrm>
+            <a:off x="1691640" y="4297680"/>
+            <a:ext cx="8686800" cy="548640"/>
           </a:xfrm>
           <a:prstGeom prst="rect">
             <a:avLst/>
@@ -4418,14 +4495,14 @@
       </p:sp>
       <p:sp>
         <p:nvSpPr>
-          <p:cNvPr id="15" name="TextBox 14"/>
-          <p:cNvSpPr txBox="1"/>
-          <p:nvPr/>
-        </p:nvSpPr>
-        <p:spPr>
-          <a:xfrm>
-            <a:off x="1691640" y="6217920"/>
-            <a:ext cx="5486400" cy="365760"/>
+          <p:cNvPr id="17" name="TextBox 16"/>
+          <p:cNvSpPr txBox="1"/>
+          <p:nvPr/>
+        </p:nvSpPr>
+        <p:spPr>
+          <a:xfrm>
+            <a:off x="1691640" y="4846320"/>
+            <a:ext cx="5486400" cy="320040"/>
           </a:xfrm>
           <a:prstGeom prst="rect">
             <a:avLst/>
@@ -4452,7 +4529,41 @@
       </p:sp>
       <p:sp>
         <p:nvSpPr>
-          <p:cNvPr id="16" name="Rectangle 15"/>
+          <p:cNvPr id="18" name="TextBox 17"/>
+          <p:cNvSpPr txBox="1"/>
+          <p:nvPr/>
+        </p:nvSpPr>
+        <p:spPr>
+          <a:xfrm>
+            <a:off x="1691640" y="6126480"/>
+            <a:ext cx="10058400" cy="457200"/>
+          </a:xfrm>
+          <a:prstGeom prst="rect">
+            <a:avLst/>
+          </a:prstGeom>
+          <a:noFill/>
+        </p:spPr>
+        <p:txBody>
+          <a:bodyPr wrap="square">
+            <a:spAutoFit/>
+          </a:bodyPr>
+          <a:lstStyle/>
+          <a:p>
+            <a:pPr algn="l"/>
+            <a:r>
+              <a:rPr sz="950" b="0" i="0">
+                <a:solidFill>
+                  <a:srgbClr val="88AACC"/>
+                </a:solidFill>
+              </a:rPr>
+              <a:t>📞 +91 8329925318   |   ✉ cortexaitechnologies@zohomail.in   |   📍 Pune, Maharashtra, India 411034</a:t>
+            </a:r>
+          </a:p>
+        </p:txBody>
+      </p:sp>
+      <p:sp>
+        <p:nvSpPr>
+          <p:cNvPr id="19" name="Rectangle 18"/>
           <p:cNvSpPr/>
           <p:nvPr/>
         </p:nvSpPr>
@@ -4495,7 +4606,7 @@
       </p:sp>
       <p:sp>
         <p:nvSpPr>
-          <p:cNvPr id="17" name="TextBox 16"/>
+          <p:cNvPr id="20" name="TextBox 19"/>
           <p:cNvSpPr txBox="1"/>
           <p:nvPr/>
         </p:nvSpPr>
@@ -17245,8 +17356,8 @@
         </p:nvSpPr>
         <p:spPr>
           <a:xfrm>
-            <a:off x="274320" y="5166360"/>
-            <a:ext cx="11612880" cy="1417320"/>
+            <a:off x="274320" y="5029200"/>
+            <a:ext cx="11612880" cy="1554480"/>
           </a:xfrm>
           <a:prstGeom prst="rect">
             <a:avLst/>
@@ -17288,28 +17399,28 @@
         </p:nvSpPr>
         <p:spPr>
           <a:xfrm>
-            <a:off x="274320" y="5440680"/>
-            <a:ext cx="11612880" cy="548640"/>
-          </a:xfrm>
-          <a:prstGeom prst="rect">
-            <a:avLst/>
-          </a:prstGeom>
-          <a:noFill/>
-        </p:spPr>
-        <p:txBody>
-          <a:bodyPr wrap="square">
-            <a:spAutoFit/>
-          </a:bodyPr>
-          <a:lstStyle/>
-          <a:p>
-            <a:pPr algn="ctr"/>
-            <a:r>
-              <a:rPr sz="1400" b="1" i="0">
+            <a:off x="274320" y="5230368"/>
+            <a:ext cx="11612880" cy="502920"/>
+          </a:xfrm>
+          <a:prstGeom prst="rect">
+            <a:avLst/>
+          </a:prstGeom>
+          <a:noFill/>
+        </p:spPr>
+        <p:txBody>
+          <a:bodyPr wrap="square">
+            <a:spAutoFit/>
+          </a:bodyPr>
+          <a:lstStyle/>
+          <a:p>
+            <a:pPr algn="ctr"/>
+            <a:r>
+              <a:rPr sz="1350" b="1" i="0">
                 <a:solidFill>
                   <a:srgbClr val="FFFFFF"/>
                 </a:solidFill>
               </a:rPr>
-              <a:t>📧 sales@cortexai.in     |     📞 +91 98765 43210     |     🌐 www.cortexai.in/clms</a:t>
+              <a:t>📞 +91 8329925318     |     ✉ cortexaitechnologies@zohomail.in</a:t>
             </a:r>
           </a:p>
         </p:txBody>
@@ -17322,28 +17433,62 @@
         </p:nvSpPr>
         <p:spPr>
           <a:xfrm>
-            <a:off x="274320" y="5989320"/>
-            <a:ext cx="11612880" cy="411480"/>
-          </a:xfrm>
-          <a:prstGeom prst="rect">
-            <a:avLst/>
-          </a:prstGeom>
-          <a:noFill/>
-        </p:spPr>
-        <p:txBody>
-          <a:bodyPr wrap="square">
-            <a:spAutoFit/>
-          </a:bodyPr>
-          <a:lstStyle/>
-          <a:p>
-            <a:pPr algn="ctr"/>
-            <a:r>
-              <a:rPr sz="1000" b="0" i="0">
+            <a:off x="274320" y="5687568"/>
+            <a:ext cx="11612880" cy="365760"/>
+          </a:xfrm>
+          <a:prstGeom prst="rect">
+            <a:avLst/>
+          </a:prstGeom>
+          <a:noFill/>
+        </p:spPr>
+        <p:txBody>
+          <a:bodyPr wrap="square">
+            <a:spAutoFit/>
+          </a:bodyPr>
+          <a:lstStyle/>
+          <a:p>
+            <a:pPr algn="ctr"/>
+            <a:r>
+              <a:rPr sz="1100" b="0" i="0">
+                <a:solidFill>
+                  <a:srgbClr val="FFFFFF"/>
+                </a:solidFill>
+              </a:rPr>
+              <a:t>📍 Pune, Maharashtra, India 411034</a:t>
+            </a:r>
+          </a:p>
+        </p:txBody>
+      </p:sp>
+      <p:sp>
+        <p:nvSpPr>
+          <p:cNvPr id="33" name="TextBox 32"/>
+          <p:cNvSpPr txBox="1"/>
+          <p:nvPr/>
+        </p:nvSpPr>
+        <p:spPr>
+          <a:xfrm>
+            <a:off x="274320" y="6108192"/>
+            <a:ext cx="11612880" cy="365760"/>
+          </a:xfrm>
+          <a:prstGeom prst="rect">
+            <a:avLst/>
+          </a:prstGeom>
+          <a:noFill/>
+        </p:spPr>
+        <p:txBody>
+          <a:bodyPr wrap="square">
+            <a:spAutoFit/>
+          </a:bodyPr>
+          <a:lstStyle/>
+          <a:p>
+            <a:pPr algn="ctr"/>
+            <a:r>
+              <a:rPr sz="950" b="0" i="0">
                 <a:solidFill>
                   <a:srgbClr val="FFCCCC"/>
                 </a:solidFill>
               </a:rPr>
-              <a:t>Cortex Technologies Pvt. Ltd.  ·  Making Calibration Labs Smarter, Faster, Compliant</a:t>
+              <a:t>Cortex AI Technologies  ·  Making Calibration Labs Smarter, Faster, Compliant</a:t>
             </a:r>
           </a:p>
         </p:txBody>

</xml_diff>